<commit_message>
AutomaTivio: ALT Light fecha 100% tirando a alavancagem só da linha do Caixa
Co-Authored-By: Claude Opus 5.5 <noreply@anthropic.com>
</commit_message>
<xml_diff>
--- a/AutomaTivio/saida/2026-09/pptx/Tivio ALT Light - Relatório de Gestão - Setembro 2026.pptx
+++ b/AutomaTivio/saida/2026-09/pptx/Tivio ALT Light - Relatório de Gestão - Setembro 2026.pptx
@@ -4621,7 +4621,7 @@
         <p:spPr>
           <a:xfrm>
             <a:off x="498960" y="6231211"/>
-            <a:ext cx="2004052" cy="151200"/>
+            <a:ext cx="2581324" cy="151200"/>
           </a:xfrm>
           <a:prstGeom prst="rect">
             <a:avLst/>
@@ -4658,7 +4658,7 @@
         <p:spPr>
           <a:xfrm>
             <a:off x="498960" y="6387609"/>
-            <a:ext cx="2004052" cy="189000"/>
+            <a:ext cx="2581324" cy="189000"/>
           </a:xfrm>
           <a:prstGeom prst="rect">
             <a:avLst/>
@@ -4694,16 +4694,16 @@
         </p:nvSpPr>
         <p:spPr>
           <a:xfrm>
-            <a:off x="2622493" y="6231211"/>
-            <a:ext cx="1711423" cy="151200"/>
-          </a:xfrm>
-          <a:prstGeom prst="rect">
-            <a:avLst/>
-          </a:prstGeom>
-          <a:noFill/>
-        </p:spPr>
-        <p:txBody>
-          <a:bodyPr wrap="none" lIns="0" rIns="0" tIns="0" bIns="0" anchor="t"/>
+            <a:off x="3177562" y="6089934"/>
+            <a:ext cx="1554761" cy="292477"/>
+          </a:xfrm>
+          <a:prstGeom prst="rect">
+            <a:avLst/>
+          </a:prstGeom>
+          <a:noFill/>
+        </p:spPr>
+        <p:txBody>
+          <a:bodyPr wrap="square" lIns="0" rIns="0" tIns="0" bIns="0" anchor="t"/>
           <a:lstStyle/>
           <a:p>
             <a:pPr algn="l">
@@ -4718,6 +4718,186 @@
                 </a:solidFill>
                 <a:latin typeface="Versos"/>
               </a:rPr>
+              <a:t>FIDCs</a:t>
+            </a:r>
+          </a:p>
+          <a:p>
+            <a:pPr algn="l">
+              <a:lnSpc>
+                <a:spcPts val="1113"/>
+              </a:lnSpc>
+            </a:pPr>
+            <a:r>
+              <a:rPr sz="1012" b="1" i="0">
+                <a:solidFill>
+                  <a:srgbClr val="FFFFFF"/>
+                </a:solidFill>
+                <a:latin typeface="Versos"/>
+              </a:rPr>
+              <a:t>Cota Sênior</a:t>
+            </a:r>
+          </a:p>
+        </p:txBody>
+      </p:sp>
+      <p:sp>
+        <p:nvSpPr>
+          <p:cNvPr id="46" name="TextBox 45"/>
+          <p:cNvSpPr txBox="1"/>
+          <p:nvPr/>
+        </p:nvSpPr>
+        <p:spPr>
+          <a:xfrm>
+            <a:off x="3177562" y="6387609"/>
+            <a:ext cx="1616951" cy="189000"/>
+          </a:xfrm>
+          <a:prstGeom prst="rect">
+            <a:avLst/>
+          </a:prstGeom>
+          <a:noFill/>
+        </p:spPr>
+        <p:txBody>
+          <a:bodyPr wrap="none" lIns="0" rIns="0" tIns="0" bIns="0" anchor="t"/>
+          <a:lstStyle/>
+          <a:p>
+            <a:pPr algn="l">
+              <a:lnSpc>
+                <a:spcPts val="1375"/>
+              </a:lnSpc>
+            </a:pPr>
+            <a:r>
+              <a:rPr sz="1250" b="1" i="0">
+                <a:solidFill>
+                  <a:srgbClr val="FFFFFF"/>
+                </a:solidFill>
+                <a:latin typeface="Versos"/>
+              </a:rPr>
+              <a:t>25,9%</a:t>
+            </a:r>
+          </a:p>
+        </p:txBody>
+      </p:sp>
+      <p:sp>
+        <p:nvSpPr>
+          <p:cNvPr id="47" name="TextBox 46"/>
+          <p:cNvSpPr txBox="1"/>
+          <p:nvPr/>
+        </p:nvSpPr>
+        <p:spPr>
+          <a:xfrm>
+            <a:off x="4929001" y="6089934"/>
+            <a:ext cx="1410766" cy="292477"/>
+          </a:xfrm>
+          <a:prstGeom prst="rect">
+            <a:avLst/>
+          </a:prstGeom>
+          <a:noFill/>
+        </p:spPr>
+        <p:txBody>
+          <a:bodyPr wrap="square" lIns="0" rIns="0" tIns="0" bIns="0" anchor="t"/>
+          <a:lstStyle/>
+          <a:p>
+            <a:pPr algn="l">
+              <a:lnSpc>
+                <a:spcPts val="1113"/>
+              </a:lnSpc>
+            </a:pPr>
+            <a:r>
+              <a:rPr sz="1012" b="0" i="0">
+                <a:solidFill>
+                  <a:srgbClr val="2B3744"/>
+                </a:solidFill>
+                <a:latin typeface="Versos"/>
+              </a:rPr>
+              <a:t>Crédito</a:t>
+            </a:r>
+          </a:p>
+          <a:p>
+            <a:pPr algn="l">
+              <a:lnSpc>
+                <a:spcPts val="1113"/>
+              </a:lnSpc>
+            </a:pPr>
+            <a:r>
+              <a:rPr sz="1012" b="1" i="0">
+                <a:solidFill>
+                  <a:srgbClr val="2B3744"/>
+                </a:solidFill>
+                <a:latin typeface="Versos"/>
+              </a:rPr>
+              <a:t>Privado</a:t>
+            </a:r>
+          </a:p>
+        </p:txBody>
+      </p:sp>
+      <p:sp>
+        <p:nvSpPr>
+          <p:cNvPr id="48" name="TextBox 47"/>
+          <p:cNvSpPr txBox="1"/>
+          <p:nvPr/>
+        </p:nvSpPr>
+        <p:spPr>
+          <a:xfrm>
+            <a:off x="4929001" y="6387609"/>
+            <a:ext cx="1467197" cy="189000"/>
+          </a:xfrm>
+          <a:prstGeom prst="rect">
+            <a:avLst/>
+          </a:prstGeom>
+          <a:noFill/>
+        </p:spPr>
+        <p:txBody>
+          <a:bodyPr wrap="none" lIns="0" rIns="0" tIns="0" bIns="0" anchor="t"/>
+          <a:lstStyle/>
+          <a:p>
+            <a:pPr algn="l">
+              <a:lnSpc>
+                <a:spcPts val="1375"/>
+              </a:lnSpc>
+            </a:pPr>
+            <a:r>
+              <a:rPr sz="1250" b="1" i="0">
+                <a:solidFill>
+                  <a:srgbClr val="2B3744"/>
+                </a:solidFill>
+                <a:latin typeface="Versos"/>
+              </a:rPr>
+              <a:t>23,8%</a:t>
+            </a:r>
+          </a:p>
+        </p:txBody>
+      </p:sp>
+      <p:sp>
+        <p:nvSpPr>
+          <p:cNvPr id="49" name="TextBox 48"/>
+          <p:cNvSpPr txBox="1"/>
+          <p:nvPr/>
+        </p:nvSpPr>
+        <p:spPr>
+          <a:xfrm>
+            <a:off x="6495457" y="6011381"/>
+            <a:ext cx="630589" cy="120960"/>
+          </a:xfrm>
+          <a:prstGeom prst="rect">
+            <a:avLst/>
+          </a:prstGeom>
+          <a:noFill/>
+        </p:spPr>
+        <p:txBody>
+          <a:bodyPr wrap="none" lIns="0" rIns="0" tIns="0" bIns="0" anchor="t"/>
+          <a:lstStyle/>
+          <a:p>
+            <a:pPr algn="l">
+              <a:lnSpc>
+                <a:spcPts val="870"/>
+              </a:lnSpc>
+            </a:pPr>
+            <a:r>
+              <a:rPr sz="791" b="0" i="0">
+                <a:solidFill>
+                  <a:srgbClr val="2B3744"/>
+                </a:solidFill>
+                <a:latin typeface="Versos"/>
+              </a:rPr>
               <a:t>Liquidez</a:t>
             </a:r>
           </a:p>
@@ -4725,248 +4905,105 @@
       </p:sp>
       <p:sp>
         <p:nvSpPr>
-          <p:cNvPr id="46" name="TextBox 45"/>
-          <p:cNvSpPr txBox="1"/>
-          <p:nvPr/>
-        </p:nvSpPr>
-        <p:spPr>
-          <a:xfrm>
-            <a:off x="2622493" y="6387609"/>
-            <a:ext cx="1711423" cy="189000"/>
-          </a:xfrm>
-          <a:prstGeom prst="rect">
-            <a:avLst/>
-          </a:prstGeom>
-          <a:noFill/>
-        </p:spPr>
-        <p:txBody>
-          <a:bodyPr wrap="none" lIns="0" rIns="0" tIns="0" bIns="0" anchor="t"/>
-          <a:lstStyle/>
-          <a:p>
-            <a:pPr algn="l">
-              <a:lnSpc>
-                <a:spcPts val="1375"/>
-              </a:lnSpc>
-            </a:pPr>
-            <a:r>
-              <a:rPr sz="1250" b="1" i="0">
+          <p:cNvPr id="50" name="TextBox 49"/>
+          <p:cNvSpPr txBox="1"/>
+          <p:nvPr/>
+        </p:nvSpPr>
+        <p:spPr>
+          <a:xfrm>
+            <a:off x="6495457" y="6137066"/>
+            <a:ext cx="630589" cy="181440"/>
+          </a:xfrm>
+          <a:prstGeom prst="rect">
+            <a:avLst/>
+          </a:prstGeom>
+          <a:noFill/>
+        </p:spPr>
+        <p:txBody>
+          <a:bodyPr wrap="none" lIns="0" rIns="0" tIns="0" bIns="0" anchor="t"/>
+          <a:lstStyle/>
+          <a:p>
+            <a:pPr algn="l">
+              <a:lnSpc>
+                <a:spcPts val="1342"/>
+              </a:lnSpc>
+            </a:pPr>
+            <a:r>
+              <a:rPr sz="1220" b="1" i="0">
+                <a:solidFill>
+                  <a:srgbClr val="2B3744"/>
+                </a:solidFill>
+                <a:latin typeface="Versos"/>
+              </a:rPr>
+              <a:t>8,2%</a:t>
+            </a:r>
+          </a:p>
+        </p:txBody>
+      </p:sp>
+      <p:sp>
+        <p:nvSpPr>
+          <p:cNvPr id="51" name="TextBox 50"/>
+          <p:cNvSpPr txBox="1"/>
+          <p:nvPr/>
+        </p:nvSpPr>
+        <p:spPr>
+          <a:xfrm>
+            <a:off x="6495457" y="6404146"/>
+            <a:ext cx="630589" cy="75600"/>
+          </a:xfrm>
+          <a:prstGeom prst="rect">
+            <a:avLst/>
+          </a:prstGeom>
+          <a:noFill/>
+        </p:spPr>
+        <p:txBody>
+          <a:bodyPr wrap="none" lIns="0" rIns="0" tIns="0" bIns="0" anchor="t"/>
+          <a:lstStyle/>
+          <a:p>
+            <a:pPr algn="l">
+              <a:lnSpc>
+                <a:spcPts val="550"/>
+              </a:lnSpc>
+            </a:pPr>
+            <a:r>
+              <a:rPr sz="500" b="0" i="0">
                 <a:solidFill>
                   <a:srgbClr val="FFFFFF"/>
                 </a:solidFill>
                 <a:latin typeface="Versos"/>
               </a:rPr>
-              <a:t>34,4%</a:t>
-            </a:r>
-          </a:p>
-        </p:txBody>
-      </p:sp>
-      <p:sp>
-        <p:nvSpPr>
-          <p:cNvPr id="47" name="TextBox 46"/>
-          <p:cNvSpPr txBox="1"/>
-          <p:nvPr/>
-        </p:nvSpPr>
-        <p:spPr>
-          <a:xfrm>
-            <a:off x="4464652" y="6089934"/>
-            <a:ext cx="1191763" cy="292477"/>
-          </a:xfrm>
-          <a:prstGeom prst="rect">
-            <a:avLst/>
-          </a:prstGeom>
-          <a:noFill/>
-        </p:spPr>
-        <p:txBody>
-          <a:bodyPr wrap="square" lIns="0" rIns="0" tIns="0" bIns="0" anchor="t"/>
-          <a:lstStyle/>
-          <a:p>
-            <a:pPr algn="l">
-              <a:lnSpc>
-                <a:spcPts val="1113"/>
-              </a:lnSpc>
-            </a:pPr>
-            <a:r>
-              <a:rPr sz="1012" b="0" i="0">
-                <a:solidFill>
-                  <a:srgbClr val="2B3744"/>
-                </a:solidFill>
-                <a:latin typeface="Versos"/>
-              </a:rPr>
-              <a:t>FIDCs</a:t>
-            </a:r>
-          </a:p>
-          <a:p>
-            <a:pPr algn="l">
-              <a:lnSpc>
-                <a:spcPts val="1113"/>
-              </a:lnSpc>
-            </a:pPr>
-            <a:r>
-              <a:rPr sz="1012" b="1" i="0">
-                <a:solidFill>
-                  <a:srgbClr val="2B3744"/>
-                </a:solidFill>
-                <a:latin typeface="Versos"/>
-              </a:rPr>
-              <a:t>Cota Sênior</a:t>
-            </a:r>
-          </a:p>
-        </p:txBody>
-      </p:sp>
-      <p:sp>
-        <p:nvSpPr>
-          <p:cNvPr id="48" name="TextBox 47"/>
-          <p:cNvSpPr txBox="1"/>
-          <p:nvPr/>
-        </p:nvSpPr>
-        <p:spPr>
-          <a:xfrm>
-            <a:off x="4464652" y="6387609"/>
-            <a:ext cx="1239433" cy="189000"/>
-          </a:xfrm>
-          <a:prstGeom prst="rect">
-            <a:avLst/>
-          </a:prstGeom>
-          <a:noFill/>
-        </p:spPr>
-        <p:txBody>
-          <a:bodyPr wrap="none" lIns="0" rIns="0" tIns="0" bIns="0" anchor="t"/>
-          <a:lstStyle/>
-          <a:p>
-            <a:pPr algn="l">
-              <a:lnSpc>
-                <a:spcPts val="1375"/>
-              </a:lnSpc>
-            </a:pPr>
-            <a:r>
-              <a:rPr sz="1250" b="1" i="0">
-                <a:solidFill>
-                  <a:srgbClr val="2B3744"/>
-                </a:solidFill>
-                <a:latin typeface="Versos"/>
-              </a:rPr>
-              <a:t>25,9%</a:t>
-            </a:r>
-          </a:p>
-        </p:txBody>
-      </p:sp>
-      <p:sp>
-        <p:nvSpPr>
-          <p:cNvPr id="49" name="TextBox 48"/>
-          <p:cNvSpPr txBox="1"/>
-          <p:nvPr/>
-        </p:nvSpPr>
-        <p:spPr>
-          <a:xfrm>
-            <a:off x="5853093" y="6089934"/>
-            <a:ext cx="1077654" cy="292477"/>
-          </a:xfrm>
-          <a:prstGeom prst="rect">
-            <a:avLst/>
-          </a:prstGeom>
-          <a:noFill/>
-        </p:spPr>
-        <p:txBody>
-          <a:bodyPr wrap="square" lIns="0" rIns="0" tIns="0" bIns="0" anchor="t"/>
-          <a:lstStyle/>
-          <a:p>
-            <a:pPr algn="l">
-              <a:lnSpc>
-                <a:spcPts val="1113"/>
-              </a:lnSpc>
-            </a:pPr>
-            <a:r>
-              <a:rPr sz="1012" b="0" i="0">
-                <a:solidFill>
-                  <a:srgbClr val="2B3744"/>
-                </a:solidFill>
-                <a:latin typeface="Versos"/>
-              </a:rPr>
-              <a:t>Crédito</a:t>
-            </a:r>
-          </a:p>
-          <a:p>
-            <a:pPr algn="l">
-              <a:lnSpc>
-                <a:spcPts val="1113"/>
-              </a:lnSpc>
-            </a:pPr>
-            <a:r>
-              <a:rPr sz="1012" b="1" i="0">
-                <a:solidFill>
-                  <a:srgbClr val="2B3744"/>
-                </a:solidFill>
-                <a:latin typeface="Versos"/>
-              </a:rPr>
-              <a:t>Privado</a:t>
-            </a:r>
-          </a:p>
-        </p:txBody>
-      </p:sp>
-      <p:sp>
-        <p:nvSpPr>
-          <p:cNvPr id="50" name="TextBox 49"/>
-          <p:cNvSpPr txBox="1"/>
-          <p:nvPr/>
-        </p:nvSpPr>
-        <p:spPr>
-          <a:xfrm>
-            <a:off x="5853093" y="6387609"/>
-            <a:ext cx="1120760" cy="189000"/>
-          </a:xfrm>
-          <a:prstGeom prst="rect">
-            <a:avLst/>
-          </a:prstGeom>
-          <a:noFill/>
-        </p:spPr>
-        <p:txBody>
-          <a:bodyPr wrap="none" lIns="0" rIns="0" tIns="0" bIns="0" anchor="t"/>
-          <a:lstStyle/>
-          <a:p>
-            <a:pPr algn="l">
-              <a:lnSpc>
-                <a:spcPts val="1375"/>
-              </a:lnSpc>
-            </a:pPr>
-            <a:r>
-              <a:rPr sz="1250" b="1" i="0">
-                <a:solidFill>
-                  <a:srgbClr val="2B3744"/>
-                </a:solidFill>
-                <a:latin typeface="Versos"/>
-              </a:rPr>
-              <a:t>23,8%</a:t>
-            </a:r>
-          </a:p>
-        </p:txBody>
-      </p:sp>
-      <p:sp>
-        <p:nvSpPr>
-          <p:cNvPr id="51" name="TextBox 50"/>
-          <p:cNvSpPr txBox="1"/>
-          <p:nvPr/>
-        </p:nvSpPr>
-        <p:spPr>
-          <a:xfrm>
-            <a:off x="7066828" y="6556173"/>
-            <a:ext cx="156633" cy="75600"/>
-          </a:xfrm>
-          <a:prstGeom prst="rect">
-            <a:avLst/>
-          </a:prstGeom>
-          <a:noFill/>
-        </p:spPr>
-        <p:txBody>
-          <a:bodyPr wrap="none" lIns="0" rIns="0" tIns="0" bIns="0" anchor="t"/>
-          <a:lstStyle/>
-          <a:p>
-            <a:pPr algn="l">
-              <a:lnSpc>
-                <a:spcPts val="523"/>
-              </a:lnSpc>
-            </a:pPr>
-            <a:r>
-              <a:rPr sz="476" b="1" i="0">
+              <a:t>FIP</a:t>
+            </a:r>
+          </a:p>
+        </p:txBody>
+      </p:sp>
+      <p:sp>
+        <p:nvSpPr>
+          <p:cNvPr id="52" name="TextBox 51"/>
+          <p:cNvSpPr txBox="1"/>
+          <p:nvPr/>
+        </p:nvSpPr>
+        <p:spPr>
+          <a:xfrm>
+            <a:off x="6495457" y="6489078"/>
+            <a:ext cx="630589" cy="120960"/>
+          </a:xfrm>
+          <a:prstGeom prst="rect">
+            <a:avLst/>
+          </a:prstGeom>
+          <a:noFill/>
+        </p:spPr>
+        <p:txBody>
+          <a:bodyPr wrap="none" lIns="0" rIns="0" tIns="0" bIns="0" anchor="t"/>
+          <a:lstStyle/>
+          <a:p>
+            <a:pPr algn="l">
+              <a:lnSpc>
+                <a:spcPts val="897"/>
+              </a:lnSpc>
+            </a:pPr>
+            <a:r>
+              <a:rPr sz="815" b="1" i="0">
                 <a:solidFill>
                   <a:srgbClr val="FFFFFF"/>
                 </a:solidFill>
@@ -4979,7 +5016,7 @@
       </p:sp>
       <p:sp>
         <p:nvSpPr>
-          <p:cNvPr id="52" name="TextBox 51"/>
+          <p:cNvPr id="53" name="TextBox 52"/>
           <p:cNvSpPr txBox="1"/>
           <p:nvPr/>
         </p:nvSpPr>
@@ -5025,14 +5062,14 @@
       </p:sp>
       <p:sp>
         <p:nvSpPr>
-          <p:cNvPr id="53" name="TextBox 52"/>
+          <p:cNvPr id="54" name="TextBox 53"/>
           <p:cNvSpPr txBox="1"/>
           <p:nvPr/>
         </p:nvSpPr>
         <p:spPr>
           <a:xfrm>
             <a:off x="1540586" y="6743638"/>
-            <a:ext cx="754176" cy="113400"/>
+            <a:ext cx="1230588" cy="113400"/>
           </a:xfrm>
           <a:prstGeom prst="rect">
             <a:avLst/>
@@ -5055,6 +5092,98 @@
                 </a:solidFill>
                 <a:latin typeface="Versos"/>
               </a:rPr>
+              <a:t>FIDCs Cota Sênior </a:t>
+            </a:r>
+            <a:r>
+              <a:rPr sz="744" b="1" i="0">
+                <a:solidFill>
+                  <a:srgbClr val="111111"/>
+                </a:solidFill>
+                <a:latin typeface="Versos"/>
+              </a:rPr>
+              <a:t>25,9%</a:t>
+            </a:r>
+          </a:p>
+        </p:txBody>
+      </p:sp>
+      <p:sp>
+        <p:nvSpPr>
+          <p:cNvPr id="55" name="TextBox 54"/>
+          <p:cNvSpPr txBox="1"/>
+          <p:nvPr/>
+        </p:nvSpPr>
+        <p:spPr>
+          <a:xfrm>
+            <a:off x="2988444" y="6743638"/>
+            <a:ext cx="1083045" cy="113400"/>
+          </a:xfrm>
+          <a:prstGeom prst="rect">
+            <a:avLst/>
+          </a:prstGeom>
+          <a:noFill/>
+        </p:spPr>
+        <p:txBody>
+          <a:bodyPr wrap="none" lIns="0" rIns="0" tIns="0" bIns="0" anchor="t"/>
+          <a:lstStyle/>
+          <a:p>
+            <a:pPr algn="l">
+              <a:lnSpc>
+                <a:spcPts val="892"/>
+              </a:lnSpc>
+            </a:pPr>
+            <a:r>
+              <a:rPr sz="744" b="0" i="0">
+                <a:solidFill>
+                  <a:srgbClr val="333333"/>
+                </a:solidFill>
+                <a:latin typeface="Versos"/>
+              </a:rPr>
+              <a:t>Crédito Privado </a:t>
+            </a:r>
+            <a:r>
+              <a:rPr sz="744" b="1" i="0">
+                <a:solidFill>
+                  <a:srgbClr val="111111"/>
+                </a:solidFill>
+                <a:latin typeface="Versos"/>
+              </a:rPr>
+              <a:t>23,8%</a:t>
+            </a:r>
+          </a:p>
+        </p:txBody>
+      </p:sp>
+      <p:sp>
+        <p:nvSpPr>
+          <p:cNvPr id="56" name="TextBox 55"/>
+          <p:cNvSpPr txBox="1"/>
+          <p:nvPr/>
+        </p:nvSpPr>
+        <p:spPr>
+          <a:xfrm>
+            <a:off x="4294434" y="6743638"/>
+            <a:ext cx="690417" cy="113400"/>
+          </a:xfrm>
+          <a:prstGeom prst="rect">
+            <a:avLst/>
+          </a:prstGeom>
+          <a:noFill/>
+        </p:spPr>
+        <p:txBody>
+          <a:bodyPr wrap="none" lIns="0" rIns="0" tIns="0" bIns="0" anchor="t"/>
+          <a:lstStyle/>
+          <a:p>
+            <a:pPr algn="l">
+              <a:lnSpc>
+                <a:spcPts val="892"/>
+              </a:lnSpc>
+            </a:pPr>
+            <a:r>
+              <a:rPr sz="744" b="0" i="0">
+                <a:solidFill>
+                  <a:srgbClr val="333333"/>
+                </a:solidFill>
+                <a:latin typeface="Versos"/>
+              </a:rPr>
               <a:t>Liquidez </a:t>
             </a:r>
             <a:r>
@@ -5064,21 +5193,21 @@
                 </a:solidFill>
                 <a:latin typeface="Versos"/>
               </a:rPr>
-              <a:t>34,4%</a:t>
-            </a:r>
-          </a:p>
-        </p:txBody>
-      </p:sp>
-      <p:sp>
-        <p:nvSpPr>
-          <p:cNvPr id="54" name="TextBox 53"/>
-          <p:cNvSpPr txBox="1"/>
-          <p:nvPr/>
-        </p:nvSpPr>
-        <p:spPr>
-          <a:xfrm>
-            <a:off x="2530355" y="6743638"/>
-            <a:ext cx="1230588" cy="113400"/>
+              <a:t>8,2%</a:t>
+            </a:r>
+          </a:p>
+        </p:txBody>
+      </p:sp>
+      <p:sp>
+        <p:nvSpPr>
+          <p:cNvPr id="57" name="TextBox 56"/>
+          <p:cNvSpPr txBox="1"/>
+          <p:nvPr/>
+        </p:nvSpPr>
+        <p:spPr>
+          <a:xfrm>
+            <a:off x="5222896" y="6743638"/>
+            <a:ext cx="462898" cy="113400"/>
           </a:xfrm>
           <a:prstGeom prst="rect">
             <a:avLst/>
@@ -5101,7 +5230,7 @@
                 </a:solidFill>
                 <a:latin typeface="Versos"/>
               </a:rPr>
-              <a:t>FIDCs Cota Sênior </a:t>
+              <a:t>FIP </a:t>
             </a:r>
             <a:r>
               <a:rPr sz="744" b="1" i="0">
@@ -5110,98 +5239,6 @@
                 </a:solidFill>
                 <a:latin typeface="Versos"/>
               </a:rPr>
-              <a:t>25,9%</a:t>
-            </a:r>
-          </a:p>
-        </p:txBody>
-      </p:sp>
-      <p:sp>
-        <p:nvSpPr>
-          <p:cNvPr id="55" name="TextBox 54"/>
-          <p:cNvSpPr txBox="1"/>
-          <p:nvPr/>
-        </p:nvSpPr>
-        <p:spPr>
-          <a:xfrm>
-            <a:off x="3978213" y="6743638"/>
-            <a:ext cx="1083045" cy="113400"/>
-          </a:xfrm>
-          <a:prstGeom prst="rect">
-            <a:avLst/>
-          </a:prstGeom>
-          <a:noFill/>
-        </p:spPr>
-        <p:txBody>
-          <a:bodyPr wrap="none" lIns="0" rIns="0" tIns="0" bIns="0" anchor="t"/>
-          <a:lstStyle/>
-          <a:p>
-            <a:pPr algn="l">
-              <a:lnSpc>
-                <a:spcPts val="892"/>
-              </a:lnSpc>
-            </a:pPr>
-            <a:r>
-              <a:rPr sz="744" b="0" i="0">
-                <a:solidFill>
-                  <a:srgbClr val="333333"/>
-                </a:solidFill>
-                <a:latin typeface="Versos"/>
-              </a:rPr>
-              <a:t>Crédito Privado </a:t>
-            </a:r>
-            <a:r>
-              <a:rPr sz="744" b="1" i="0">
-                <a:solidFill>
-                  <a:srgbClr val="111111"/>
-                </a:solidFill>
-                <a:latin typeface="Versos"/>
-              </a:rPr>
-              <a:t>23,8%</a:t>
-            </a:r>
-          </a:p>
-        </p:txBody>
-      </p:sp>
-      <p:sp>
-        <p:nvSpPr>
-          <p:cNvPr id="56" name="TextBox 55"/>
-          <p:cNvSpPr txBox="1"/>
-          <p:nvPr/>
-        </p:nvSpPr>
-        <p:spPr>
-          <a:xfrm>
-            <a:off x="5284203" y="6743638"/>
-            <a:ext cx="462898" cy="113400"/>
-          </a:xfrm>
-          <a:prstGeom prst="rect">
-            <a:avLst/>
-          </a:prstGeom>
-          <a:noFill/>
-        </p:spPr>
-        <p:txBody>
-          <a:bodyPr wrap="none" lIns="0" rIns="0" tIns="0" bIns="0" anchor="t"/>
-          <a:lstStyle/>
-          <a:p>
-            <a:pPr algn="l">
-              <a:lnSpc>
-                <a:spcPts val="892"/>
-              </a:lnSpc>
-            </a:pPr>
-            <a:r>
-              <a:rPr sz="744" b="0" i="0">
-                <a:solidFill>
-                  <a:srgbClr val="333333"/>
-                </a:solidFill>
-                <a:latin typeface="Versos"/>
-              </a:rPr>
-              <a:t>FIP </a:t>
-            </a:r>
-            <a:r>
-              <a:rPr sz="744" b="1" i="0">
-                <a:solidFill>
-                  <a:srgbClr val="111111"/>
-                </a:solidFill>
-                <a:latin typeface="Versos"/>
-              </a:rPr>
               <a:t>2,4%</a:t>
             </a:r>
           </a:p>
@@ -5209,7 +5246,7 @@
       </p:sp>
       <p:sp>
         <p:nvSpPr>
-          <p:cNvPr id="57" name="TextBox 56"/>
+          <p:cNvPr id="58" name="TextBox 57"/>
           <p:cNvSpPr txBox="1"/>
           <p:nvPr/>
         </p:nvSpPr>
@@ -5246,7 +5283,7 @@
       </p:sp>
       <p:sp>
         <p:nvSpPr>
-          <p:cNvPr id="58" name="TextBox 57"/>
+          <p:cNvPr id="59" name="TextBox 58"/>
           <p:cNvSpPr txBox="1"/>
           <p:nvPr/>
         </p:nvSpPr>
@@ -5283,7 +5320,7 @@
       </p:sp>
       <p:sp>
         <p:nvSpPr>
-          <p:cNvPr id="59" name="TextBox 58"/>
+          <p:cNvPr id="60" name="TextBox 59"/>
           <p:cNvSpPr txBox="1"/>
           <p:nvPr/>
         </p:nvSpPr>
@@ -5320,7 +5357,7 @@
       </p:sp>
       <p:sp>
         <p:nvSpPr>
-          <p:cNvPr id="60" name="TextBox 59"/>
+          <p:cNvPr id="61" name="TextBox 60"/>
           <p:cNvSpPr txBox="1"/>
           <p:nvPr/>
         </p:nvSpPr>
@@ -5357,7 +5394,7 @@
       </p:sp>
       <p:sp>
         <p:nvSpPr>
-          <p:cNvPr id="61" name="TextBox 60"/>
+          <p:cNvPr id="62" name="TextBox 61"/>
           <p:cNvSpPr txBox="1"/>
           <p:nvPr/>
         </p:nvSpPr>
@@ -5394,7 +5431,7 @@
       </p:sp>
       <p:sp>
         <p:nvSpPr>
-          <p:cNvPr id="62" name="TextBox 61"/>
+          <p:cNvPr id="63" name="TextBox 62"/>
           <p:cNvSpPr txBox="1"/>
           <p:nvPr/>
         </p:nvSpPr>
@@ -5431,7 +5468,7 @@
       </p:sp>
       <p:sp>
         <p:nvSpPr>
-          <p:cNvPr id="63" name="TextBox 62"/>
+          <p:cNvPr id="64" name="TextBox 63"/>
           <p:cNvSpPr txBox="1"/>
           <p:nvPr/>
         </p:nvSpPr>
@@ -5468,7 +5505,7 @@
       </p:sp>
       <p:sp>
         <p:nvSpPr>
-          <p:cNvPr id="64" name="TextBox 63"/>
+          <p:cNvPr id="65" name="TextBox 64"/>
           <p:cNvSpPr txBox="1"/>
           <p:nvPr/>
         </p:nvSpPr>

</xml_diff>